<commit_message>
feat: expand research agent capabilities by implementing intent, planning, and validation services alongside new data providers.
</commit_message>
<xml_diff>
--- a/artifacts/ppt/test_ppt.pptx
+++ b/artifacts/ppt/test_ppt.pptx
@@ -3105,6 +3105,11 @@
           <a:lstStyle/>
           <a:p>
             <a:r>
+              <a:rPr>
+                <a:solidFill>
+                  <a:srgbClr val="1E293B"/>
+                </a:solidFill>
+              </a:rPr>
               <a:t>Test PowerPoint Title</a:t>
             </a:r>
           </a:p>
@@ -3126,6 +3131,11 @@
           <a:lstStyle/>
           <a:p>
             <a:r>
+              <a:rPr>
+                <a:solidFill>
+                  <a:srgbClr val="334155"/>
+                </a:solidFill>
+              </a:rPr>
               <a:t>Business Intelligence Brief | Powered by AI Agent Framework</a:t>
             </a:r>
           </a:p>
@@ -3165,6 +3175,11 @@
           <a:lstStyle/>
           <a:p>
             <a:r>
+              <a:rPr>
+                <a:solidFill>
+                  <a:srgbClr val="1E293B"/>
+                </a:solidFill>
+              </a:rPr>
               <a:t>Slide 1 Title</a:t>
             </a:r>
           </a:p>
@@ -3186,12 +3201,22 @@
           <a:lstStyle/>
           <a:p>
             <a:r>
+              <a:rPr>
+                <a:solidFill>
+                  <a:srgbClr val="334155"/>
+                </a:solidFill>
+              </a:rPr>
               <a:t>bullet 1</a:t>
             </a:r>
           </a:p>
           <a:p>
             <a:pPr/>
             <a:r>
+              <a:rPr>
+                <a:solidFill>
+                  <a:srgbClr val="334155"/>
+                </a:solidFill>
+              </a:rPr>
               <a:t>bullet 2</a:t>
             </a:r>
           </a:p>

</xml_diff>